<commit_message>
Remove Q&A closing and links for submission
</commit_message>
<xml_diff>
--- a/presentation.pptx
+++ b/presentation.pptx
@@ -724,7 +724,7 @@
           <a:lstStyle/>
           <a:p>
             <a:r>
-              <a:t>약 1분. 이 페이지의 링크로 서비스를 열어 한 건의 제보를 따라가며 시연합니다. 테스트용 제보임을 명시하고, 사진과 위치 등록, AI 결과, 담당자 처리, 시민 조회 순서로 보여줍니다. 제공된 스크린샷으로 관리 화면 구성을 확인했습니다. 사이트 직접 접속은 제작 환경에서 HTTP 403을 반환해 기능 동작은 직접 검증하지 못했습니다. 발표 전에 접속과 시연 데이터를 확인하세요.</a:t>
+              <a:t>약 1분. 서비스를 열어 한 건의 제보를 따라가며 시연합니다. 테스트용 제보임을 명시하고, 사진과 위치 등록, AI 결과, 담당자 처리, 시민 조회 순서로 보여줍니다. 제공된 스크린샷으로 관리 화면 구성을 확인했습니다. 사이트 직접 접속은 제작 환경에서 HTTP 403을 반환해 기능 동작은 직접 검증하지 못했습니다. 발표 전에 접속과 시연 데이터를 확인하세요.</a:t>
             </a:r>
           </a:p>
         </p:txBody>
@@ -7915,48 +7915,6 @@
           </a:p>
         </p:txBody>
       </p:sp>
-      <p:sp>
-        <p:nvSpPr>
-          <p:cNvPr id="24" name="TextBox 23"/>
-          <p:cNvSpPr txBox="1"/>
-          <p:nvPr/>
-        </p:nvSpPr>
-        <p:spPr>
-          <a:xfrm>
-            <a:off x="640080" y="5806440"/>
-            <a:ext cx="10972800" cy="365760"/>
-          </a:xfrm>
-          <a:prstGeom prst="rect">
-            <a:avLst/>
-          </a:prstGeom>
-          <a:noFill/>
-        </p:spPr>
-        <p:txBody>
-          <a:bodyPr wrap="square">
-            <a:spAutoFit/>
-          </a:bodyPr>
-          <a:lstStyle/>
-          <a:p>
-            <a:pPr>
-              <a:spcAft>
-                <a:spcPts val="1000"/>
-              </a:spcAft>
-              <a:defRPr sz="1500" b="0">
-                <a:solidFill>
-                  <a:srgbClr val="23785A"/>
-                </a:solidFill>
-                <a:latin typeface="Noto Sans CJK KR"/>
-              </a:defRPr>
-            </a:pPr>
-            <a:r>
-              <a:rPr>
-                <a:hlinkClick r:id="rId2"/>
-              </a:rPr>
-              <a:t>서비스 접속: https://pineshield-forest.vercel.app/#reports</a:t>
-            </a:r>
-          </a:p>
-        </p:txBody>
-      </p:sp>
     </p:spTree>
   </p:cSld>
   <p:clrMapOvr>
@@ -8385,7 +8343,7 @@
               </a:defRPr>
             </a:pPr>
             <a:r>
-              <a:t>감사합니다. 질문을 받겠습니다.</a:t>
+              <a:t>감사합니다.</a:t>
             </a:r>
           </a:p>
         </p:txBody>

</xml_diff>